<commit_message>
Report/slides: 20-thread numbers from the rerun (13.5x, 1127 GFLOP/s); note the two reproducibly slow layers
Co-Authored-By: Claude Opus 5.5 <noreply@anthropic.com>
Claude-Session: https://claude.ai/code/session_01AeVaHM9UcLNRWUmMTDhqz2
</commit_message>
<xml_diff>
--- a/docs/milestone/om/slides/om_s1_kernel.pptx
+++ b/docs/milestone/om/slides/om_s1_kernel.pptx
@@ -116,26 +116,26 @@
   <p:extLst>
     <p:ext uri="{521415D9-36F7-43E2-AB2F-B90AF26B5E84}">
       <p14:sectionLst xmlns:p14="http://schemas.microsoft.com/office/powerpoint/2010/main">
-        <p14:section name="Kernel" id="{832e8ed1-e3c4-4ca0-a3a7-6f763ae085ec}">
+        <p14:section name="Kernel" id="{72355040-6252-fb6a-4b16-dc8115586518}">
           <p14:sldIdLst>
             <p14:sldId id="256"/>
             <p14:sldId id="257"/>
             <p14:sldId id="258"/>
           </p14:sldIdLst>
         </p14:section>
-        <p14:section name="Design" id="{8cb0eac6-170c-8f61-99b0-80c9d1ad49c6}">
+        <p14:section name="Design" id="{54227faf-c566-d6a7-bd9e-c0667ce55736}">
           <p14:sldIdLst>
             <p14:sldId id="259"/>
           </p14:sldIdLst>
         </p14:section>
-        <p14:section name="Results" id="{ea18c641-8c3c-d028-2560-71f8fda9bade}">
+        <p14:section name="Results" id="{951b756c-0714-b6a2-650b-42515dd8481d}">
           <p14:sldIdLst>
             <p14:sldId id="260"/>
             <p14:sldId id="261"/>
             <p14:sldId id="262"/>
           </p14:sldIdLst>
         </p14:section>
-        <p14:section name="Layout" id="{67c43913-6df9-8164-f2fd-272ff40ce755}">
+        <p14:section name="Layout" id="{a01c6850-757d-4ce4-4474-d67d03c3f198}">
           <p14:sldIdLst>
             <p14:sldId id="263"/>
             <p14:sldId id="264"/>
@@ -1978,7 +1978,7 @@
           <a:p>
             <a:r>
               <a:rPr lang="en-US" dirty="0"/>
-              <a:t>v3 runs all 32 layers in 5.1 ms on 20 cores versus 69.5 ms on one, 13.7 times, 1140 GFLOP/s. Next steps: software pipelining, cache blocking for the two 256-channel layers, NUMA first-touch and batch 16.</a:t>
+              <a:t>v3 runs all 32 layers in 5.15 ms on 20 cores versus 69.5 ms on one, 13.5 times, 1127 GFLOP/s. Two layers stay near 50 percent in two separate runs; likely memory placement across the two sockets, which is the next thing to test. Next steps: software pipelining, cache blocking for the two 256-channel layers, NUMA first-touch and batch 16.</a:t>
             </a:r>
             <a:endParaRPr lang="en-US" dirty="0"/>
           </a:p>
@@ -3490,7 +3490,7 @@
                   <a:schemeClr val="bg1"/>
                 </a:solidFill>
               </a:rPr>
-              <a:t>20 cores: 13.7× faster, 1,140 GFLOP/s</a:t>
+              <a:t>20 cores: 13.5× faster, 1,127 GFLOP/s</a:t>
             </a:r>
             <a:endParaRPr lang="en-US" sz="4000" dirty="0"/>
           </a:p>
@@ -3528,7 +3528,7 @@
                   <a:schemeClr val="accent6"/>
                 </a:solidFill>
               </a:rPr>
-              <a:t>v3 = v2 + OpenMP, 74% of the 20-core peak at base clock.  Next: software-pipelined microkernel for the last ~20%, cache blocking for the C=256 layers, NUMA-aware threading, batch 16.</a:t>
+              <a:t>v3 = v2 + OpenMP, 73% of the 20-core peak at base clock (most layers 75–83%).  Next: software-pipelined microkernel for the last ~20%, cache blocking for the C=256 layers, NUMA-aware threading, batch 16.</a:t>
             </a:r>
             <a:endParaRPr lang="en-US" sz="1800" dirty="0"/>
           </a:p>

</xml_diff>